<commit_message>
Use even dummy values for template delta chart defaults
Set the hard-coded chart data in the bundled template to an even split per bar
(50/50 for duplication, 25/25/25/25 for the four-risk metrics) so the
un-generated template obviously reads as placeholder/dummy data. Live reports
are unaffected — these defaults are overwritten with real values at generation
(the golden reference is byte-identical). Version bump to 1.6.3.

Co-Authored-By: Claude Opus 4.8 <noreply@anthropic.com>
</commit_message>
<xml_diff>
--- a/src/report_generator/presets/templates/system-monitoring-report.pptx
+++ b/src/report_generator/presets/templates/system-monitoring-report.pptx
@@ -206,10 +206,10 @@
                 <c:formatCode>General</c:formatCode>
                 <c:ptCount val="2"/>
                 <c:pt idx="0">
-                  <c:v>96.971050161045881</c:v>
+                  <c:v>50.0</c:v>
                 </c:pt>
                 <c:pt idx="1">
-                  <c:v>96.052060829265798</c:v>
+                  <c:v>50.0</c:v>
                 </c:pt>
               </c:numCache>
             </c:numRef>
@@ -276,10 +276,10 @@
                 <c:formatCode>General</c:formatCode>
                 <c:ptCount val="2"/>
                 <c:pt idx="0">
-                  <c:v>3.0289498389541194</c:v>
+                  <c:v>50.0</c:v>
                 </c:pt>
                 <c:pt idx="1">
-                  <c:v>3.9479391707342</c:v>
+                  <c:v>50.0</c:v>
                 </c:pt>
               </c:numCache>
             </c:numRef>
@@ -500,13 +500,13 @@
                 <c:formatCode>General</c:formatCode>
                 <c:ptCount val="3"/>
                 <c:pt idx="0">
-                  <c:v>93.824738582866189</c:v>
+                  <c:v>25.0</c:v>
                 </c:pt>
                 <c:pt idx="1">
-                  <c:v>97.089767646820206</c:v>
+                  <c:v>25.0</c:v>
                 </c:pt>
                 <c:pt idx="2">
-                  <c:v>96.866554074376694</c:v>
+                  <c:v>25.0</c:v>
                 </c:pt>
               </c:numCache>
             </c:numRef>
@@ -576,13 +576,13 @@
                 <c:formatCode>General</c:formatCode>
                 <c:ptCount val="3"/>
                 <c:pt idx="0">
-                  <c:v>2.6950059860306594</c:v>
+                  <c:v>25.0</c:v>
                 </c:pt>
                 <c:pt idx="1">
-                  <c:v>0.86903246850184046</c:v>
+                  <c:v>25.0</c:v>
                 </c:pt>
                 <c:pt idx="2">
-                  <c:v>1.0649747701121905</c:v>
+                  <c:v>25.0</c:v>
                 </c:pt>
               </c:numCache>
             </c:numRef>
@@ -652,13 +652,13 @@
                 <c:formatCode>General</c:formatCode>
                 <c:ptCount val="3"/>
                 <c:pt idx="0">
-                  <c:v>2.1498772277305442</c:v>
+                  <c:v>25.0</c:v>
                 </c:pt>
                 <c:pt idx="1">
-                  <c:v>1.1105824380932967</c:v>
+                  <c:v>25.0</c:v>
                 </c:pt>
                 <c:pt idx="2">
-                  <c:v>1.1661376147990841</c:v>
+                  <c:v>25.0</c:v>
                 </c:pt>
               </c:numCache>
             </c:numRef>
@@ -728,13 +728,13 @@
                 <c:formatCode>General</c:formatCode>
                 <c:ptCount val="3"/>
                 <c:pt idx="0">
-                  <c:v>1.3303782033725911</c:v>
+                  <c:v>25.0</c:v>
                 </c:pt>
                 <c:pt idx="1">
-                  <c:v>0.93061744658464796</c:v>
+                  <c:v>25.0</c:v>
                 </c:pt>
                 <c:pt idx="2">
-                  <c:v>0.90233354071203919</c:v>
+                  <c:v>25.0</c:v>
                 </c:pt>
               </c:numCache>
             </c:numRef>
@@ -952,10 +952,10 @@
                 <c:formatCode>General</c:formatCode>
                 <c:ptCount val="2"/>
                 <c:pt idx="0">
-                  <c:v>96.971050161045881</c:v>
+                  <c:v>50.0</c:v>
                 </c:pt>
                 <c:pt idx="1">
-                  <c:v>93.702295547950527</c:v>
+                  <c:v>50.0</c:v>
                 </c:pt>
               </c:numCache>
             </c:numRef>
@@ -1022,10 +1022,10 @@
                 <c:formatCode>General</c:formatCode>
                 <c:ptCount val="2"/>
                 <c:pt idx="0">
-                  <c:v>3.0289498389541194</c:v>
+                  <c:v>50.0</c:v>
                 </c:pt>
                 <c:pt idx="1">
-                  <c:v>6.2977044520494827</c:v>
+                  <c:v>50.0</c:v>
                 </c:pt>
               </c:numCache>
             </c:numRef>
@@ -1243,10 +1243,10 @@
                 <c:formatCode>General</c:formatCode>
                 <c:ptCount val="2"/>
                 <c:pt idx="0">
-                  <c:v>65.946033049103249</c:v>
+                  <c:v>25.0</c:v>
                 </c:pt>
                 <c:pt idx="1">
-                  <c:v>14.022677494788882</c:v>
+                  <c:v>25.0</c:v>
                 </c:pt>
               </c:numCache>
             </c:numRef>
@@ -1313,10 +1313,10 @@
                 <c:formatCode>General</c:formatCode>
                 <c:ptCount val="2"/>
                 <c:pt idx="0">
-                  <c:v>19.831260027281679</c:v>
+                  <c:v>25.0</c:v>
                 </c:pt>
                 <c:pt idx="1">
-                  <c:v>15.573724287761854</c:v>
+                  <c:v>25.0</c:v>
                 </c:pt>
               </c:numCache>
             </c:numRef>
@@ -1383,10 +1383,10 @@
                 <c:formatCode>General</c:formatCode>
                 <c:ptCount val="2"/>
                 <c:pt idx="0">
-                  <c:v>6.1452471904275461</c:v>
+                  <c:v>25.0</c:v>
                 </c:pt>
                 <c:pt idx="1">
-                  <c:v>22.046223804875464</c:v>
+                  <c:v>25.0</c:v>
                 </c:pt>
               </c:numCache>
             </c:numRef>
@@ -1453,10 +1453,10 @@
                 <c:formatCode>General</c:formatCode>
                 <c:ptCount val="2"/>
                 <c:pt idx="0">
-                  <c:v>8.0774597331875206</c:v>
+                  <c:v>25.0</c:v>
                 </c:pt>
                 <c:pt idx="1">
-                  <c:v>48.357374412573805</c:v>
+                  <c:v>25.0</c:v>
                 </c:pt>
               </c:numCache>
             </c:numRef>
@@ -1674,10 +1674,10 @@
                 <c:formatCode>General</c:formatCode>
                 <c:ptCount val="2"/>
                 <c:pt idx="0">
-                  <c:v>91.563113353200137</c:v>
+                  <c:v>25.0</c:v>
                 </c:pt>
                 <c:pt idx="1">
-                  <c:v>65.300328930328021</c:v>
+                  <c:v>25.0</c:v>
                 </c:pt>
               </c:numCache>
             </c:numRef>
@@ -1744,10 +1744,10 @@
                 <c:formatCode>General</c:formatCode>
                 <c:ptCount val="2"/>
                 <c:pt idx="0">
-                  <c:v>5.5168803757830922</c:v>
+                  <c:v>25.0</c:v>
                 </c:pt>
                 <c:pt idx="1">
-                  <c:v>18.62107537854595</c:v>
+                  <c:v>25.0</c:v>
                 </c:pt>
               </c:numCache>
             </c:numRef>
@@ -1814,10 +1814,10 @@
                 <c:formatCode>General</c:formatCode>
                 <c:ptCount val="2"/>
                 <c:pt idx="0">
-                  <c:v>2.5725857976115076</c:v>
+                  <c:v>25.0</c:v>
                 </c:pt>
                 <c:pt idx="1">
-                  <c:v>13.480858824972442</c:v>
+                  <c:v>25.0</c:v>
                 </c:pt>
               </c:numCache>
             </c:numRef>
@@ -1884,10 +1884,10 @@
                 <c:formatCode>General</c:formatCode>
                 <c:ptCount val="2"/>
                 <c:pt idx="0">
-                  <c:v>0.34742047340526355</c:v>
+                  <c:v>25.0</c:v>
                 </c:pt>
                 <c:pt idx="1">
-                  <c:v>2.5977368661535891</c:v>
+                  <c:v>25.0</c:v>
                 </c:pt>
               </c:numCache>
             </c:numRef>
@@ -2105,10 +2105,10 @@
                 <c:formatCode>General</c:formatCode>
                 <c:ptCount val="2"/>
                 <c:pt idx="0">
-                  <c:v>82.550393995004484</c:v>
+                  <c:v>25.0</c:v>
                 </c:pt>
                 <c:pt idx="1">
-                  <c:v>81.740026760462342</c:v>
+                  <c:v>25.0</c:v>
                 </c:pt>
               </c:numCache>
             </c:numRef>
@@ -2175,10 +2175,10 @@
                 <c:formatCode>General</c:formatCode>
                 <c:ptCount val="2"/>
                 <c:pt idx="0">
-                  <c:v>15.355997479537963</c:v>
+                  <c:v>25.0</c:v>
                 </c:pt>
                 <c:pt idx="1">
-                  <c:v>15.981343092179129</c:v>
+                  <c:v>25.0</c:v>
                 </c:pt>
               </c:numCache>
             </c:numRef>
@@ -2245,10 +2245,10 @@
                 <c:formatCode>General</c:formatCode>
                 <c:ptCount val="2"/>
                 <c:pt idx="0">
-                  <c:v>1.5225306614771383</c:v>
+                  <c:v>25.0</c:v>
                 </c:pt>
                 <c:pt idx="1">
-                  <c:v>1.5085581226500766</c:v>
+                  <c:v>25.0</c:v>
                 </c:pt>
               </c:numCache>
             </c:numRef>
@@ -2315,10 +2315,10 @@
                 <c:formatCode>General</c:formatCode>
                 <c:ptCount val="2"/>
                 <c:pt idx="0">
-                  <c:v>0.57107786398040727</c:v>
+                  <c:v>25.0</c:v>
                 </c:pt>
                 <c:pt idx="1">
-                  <c:v>0.77007202470844049</c:v>
+                  <c:v>25.0</c:v>
                 </c:pt>
               </c:numCache>
             </c:numRef>
@@ -2536,10 +2536,10 @@
                 <c:formatCode>General</c:formatCode>
                 <c:ptCount val="2"/>
                 <c:pt idx="0">
-                  <c:v>93.824738582866189</c:v>
+                  <c:v>25.0</c:v>
                 </c:pt>
                 <c:pt idx="1">
-                  <c:v>91.952373019779344</c:v>
+                  <c:v>25.0</c:v>
                 </c:pt>
               </c:numCache>
             </c:numRef>
@@ -2606,10 +2606,10 @@
                 <c:formatCode>General</c:formatCode>
                 <c:ptCount val="2"/>
                 <c:pt idx="0">
-                  <c:v>2.6950059860306594</c:v>
+                  <c:v>25.0</c:v>
                 </c:pt>
                 <c:pt idx="1">
-                  <c:v>7.1506518897168982</c:v>
+                  <c:v>25.0</c:v>
                 </c:pt>
               </c:numCache>
             </c:numRef>
@@ -2676,10 +2676,10 @@
                 <c:formatCode>General</c:formatCode>
                 <c:ptCount val="2"/>
                 <c:pt idx="0">
-                  <c:v>2.1498772277305442</c:v>
+                  <c:v>25.0</c:v>
                 </c:pt>
                 <c:pt idx="1">
-                  <c:v>0.8969750905037609</c:v>
+                  <c:v>25.0</c:v>
                 </c:pt>
               </c:numCache>
             </c:numRef>
@@ -2746,10 +2746,10 @@
                 <c:formatCode>General</c:formatCode>
                 <c:ptCount val="2"/>
                 <c:pt idx="0">
-                  <c:v>1.3303782033725911</c:v>
+                  <c:v>25.0</c:v>
                 </c:pt>
                 <c:pt idx="1">
-                  <c:v>0</c:v>
+                  <c:v>25.0</c:v>
                 </c:pt>
               </c:numCache>
             </c:numRef>
@@ -2967,10 +2967,10 @@
                 <c:formatCode>General</c:formatCode>
                 <c:ptCount val="2"/>
                 <c:pt idx="0">
-                  <c:v>65.946033049103249</c:v>
+                  <c:v>25.0</c:v>
                 </c:pt>
                 <c:pt idx="1">
-                  <c:v>62.815123901731681</c:v>
+                  <c:v>25.0</c:v>
                 </c:pt>
               </c:numCache>
             </c:numRef>
@@ -3037,10 +3037,10 @@
                 <c:formatCode>General</c:formatCode>
                 <c:ptCount val="2"/>
                 <c:pt idx="0">
-                  <c:v>19.831260027281679</c:v>
+                  <c:v>25.0</c:v>
                 </c:pt>
                 <c:pt idx="1">
-                  <c:v>26.663177224293644</c:v>
+                  <c:v>25.0</c:v>
                 </c:pt>
               </c:numCache>
             </c:numRef>
@@ -3107,10 +3107,10 @@
                 <c:formatCode>General</c:formatCode>
                 <c:ptCount val="2"/>
                 <c:pt idx="0">
-                  <c:v>6.1452471904275461</c:v>
+                  <c:v>25.0</c:v>
                 </c:pt>
                 <c:pt idx="1">
-                  <c:v>8.1089004481493294</c:v>
+                  <c:v>25.0</c:v>
                 </c:pt>
               </c:numCache>
             </c:numRef>
@@ -3177,10 +3177,10 @@
                 <c:formatCode>General</c:formatCode>
                 <c:ptCount val="2"/>
                 <c:pt idx="0">
-                  <c:v>8.0774597331875206</c:v>
+                  <c:v>25.0</c:v>
                 </c:pt>
                 <c:pt idx="1">
-                  <c:v>2.4127984258253439</c:v>
+                  <c:v>25.0</c:v>
                 </c:pt>
               </c:numCache>
             </c:numRef>
@@ -3398,10 +3398,10 @@
                 <c:formatCode>General</c:formatCode>
                 <c:ptCount val="2"/>
                 <c:pt idx="0">
-                  <c:v>91.563113353200137</c:v>
+                  <c:v>25.0</c:v>
                 </c:pt>
                 <c:pt idx="1">
-                  <c:v>86.315417613267911</c:v>
+                  <c:v>25.0</c:v>
                 </c:pt>
               </c:numCache>
             </c:numRef>
@@ -3468,10 +3468,10 @@
                 <c:formatCode>General</c:formatCode>
                 <c:ptCount val="2"/>
                 <c:pt idx="0">
-                  <c:v>5.5168803757830922</c:v>
+                  <c:v>25.0</c:v>
                 </c:pt>
                 <c:pt idx="1">
-                  <c:v>12.205106013782602</c:v>
+                  <c:v>25.0</c:v>
                 </c:pt>
               </c:numCache>
             </c:numRef>
@@ -3538,10 +3538,10 @@
                 <c:formatCode>General</c:formatCode>
                 <c:ptCount val="2"/>
                 <c:pt idx="0">
-                  <c:v>2.5725857976115076</c:v>
+                  <c:v>25.0</c:v>
                 </c:pt>
                 <c:pt idx="1">
-                  <c:v>1.4794763729494886</c:v>
+                  <c:v>25.0</c:v>
                 </c:pt>
               </c:numCache>
             </c:numRef>
@@ -3608,10 +3608,10 @@
                 <c:formatCode>General</c:formatCode>
                 <c:ptCount val="2"/>
                 <c:pt idx="0">
-                  <c:v>0.34742047340526355</c:v>
+                  <c:v>25.0</c:v>
                 </c:pt>
                 <c:pt idx="1">
-                  <c:v>0</c:v>
+                  <c:v>25.0</c:v>
                 </c:pt>
               </c:numCache>
             </c:numRef>
@@ -3829,10 +3829,10 @@
                 <c:formatCode>General</c:formatCode>
                 <c:ptCount val="2"/>
                 <c:pt idx="0">
-                  <c:v>82.550393995004484</c:v>
+                  <c:v>25.0</c:v>
                 </c:pt>
                 <c:pt idx="1">
-                  <c:v>81.476301683774324</c:v>
+                  <c:v>25.0</c:v>
                 </c:pt>
               </c:numCache>
             </c:numRef>
@@ -3899,10 +3899,10 @@
                 <c:formatCode>General</c:formatCode>
                 <c:ptCount val="2"/>
                 <c:pt idx="0">
-                  <c:v>15.355997479537963</c:v>
+                  <c:v>25.0</c:v>
                 </c:pt>
                 <c:pt idx="1">
-                  <c:v>16.085645858023437</c:v>
+                  <c:v>25.0</c:v>
                 </c:pt>
               </c:numCache>
             </c:numRef>
@@ -3969,10 +3969,10 @@
                 <c:formatCode>General</c:formatCode>
                 <c:ptCount val="2"/>
                 <c:pt idx="0">
-                  <c:v>1.5225306614771383</c:v>
+                  <c:v>25.0</c:v>
                 </c:pt>
                 <c:pt idx="1">
-                  <c:v>2.3554090549490989</c:v>
+                  <c:v>25.0</c:v>
                 </c:pt>
               </c:numCache>
             </c:numRef>
@@ -4039,10 +4039,10 @@
                 <c:formatCode>General</c:formatCode>
                 <c:ptCount val="2"/>
                 <c:pt idx="0">
-                  <c:v>0.57107786398040727</c:v>
+                  <c:v>25.0</c:v>
                 </c:pt>
                 <c:pt idx="1">
-                  <c:v>8.2643403253150463E-2</c:v>
+                  <c:v>25.0</c:v>
                 </c:pt>
               </c:numCache>
             </c:numRef>
@@ -4260,10 +4260,10 @@
                 <c:formatCode>General</c:formatCode>
                 <c:ptCount val="2"/>
                 <c:pt idx="0">
-                  <c:v>93.824738582866189</c:v>
+                  <c:v>25.0</c:v>
                 </c:pt>
                 <c:pt idx="1">
-                  <c:v>93.771404300873968</c:v>
+                  <c:v>25.0</c:v>
                 </c:pt>
               </c:numCache>
             </c:numRef>
@@ -4330,10 +4330,10 @@
                 <c:formatCode>General</c:formatCode>
                 <c:ptCount val="2"/>
                 <c:pt idx="0">
-                  <c:v>2.6950059860306594</c:v>
+                  <c:v>25.0</c:v>
                 </c:pt>
                 <c:pt idx="1">
-                  <c:v>2.7228646027601657</c:v>
+                  <c:v>25.0</c:v>
                 </c:pt>
               </c:numCache>
             </c:numRef>
@@ -4400,10 +4400,10 @@
                 <c:formatCode>General</c:formatCode>
                 <c:ptCount val="2"/>
                 <c:pt idx="0">
-                  <c:v>2.1498772277305442</c:v>
+                  <c:v>25.0</c:v>
                 </c:pt>
                 <c:pt idx="1">
-                  <c:v>3.1829703490021108</c:v>
+                  <c:v>25.0</c:v>
                 </c:pt>
               </c:numCache>
             </c:numRef>
@@ -4470,10 +4470,10 @@
                 <c:formatCode>General</c:formatCode>
                 <c:ptCount val="2"/>
                 <c:pt idx="0">
-                  <c:v>1.3303782033725911</c:v>
+                  <c:v>25.0</c:v>
                 </c:pt>
                 <c:pt idx="1">
-                  <c:v>0.32276074736375227</c:v>
+                  <c:v>25.0</c:v>
                 </c:pt>
               </c:numCache>
             </c:numRef>
@@ -4694,13 +4694,13 @@
                 <c:formatCode>General</c:formatCode>
                 <c:ptCount val="3"/>
                 <c:pt idx="0">
-                  <c:v>96.971050161045881</c:v>
+                  <c:v>50.0</c:v>
                 </c:pt>
                 <c:pt idx="1">
-                  <c:v>98.068622366742517</c:v>
+                  <c:v>50.0</c:v>
                 </c:pt>
                 <c:pt idx="2">
-                  <c:v>98.111696909018164</c:v>
+                  <c:v>50.0</c:v>
                 </c:pt>
               </c:numCache>
             </c:numRef>
@@ -4770,13 +4770,13 @@
                 <c:formatCode>General</c:formatCode>
                 <c:ptCount val="3"/>
                 <c:pt idx="0">
-                  <c:v>3.0289498389541194</c:v>
+                  <c:v>50.0</c:v>
                 </c:pt>
                 <c:pt idx="1">
-                  <c:v>1.931377633257475</c:v>
+                  <c:v>50.0</c:v>
                 </c:pt>
                 <c:pt idx="2">
-                  <c:v>1.8883030909818361</c:v>
+                  <c:v>50.0</c:v>
                 </c:pt>
               </c:numCache>
             </c:numRef>
@@ -4997,13 +4997,13 @@
                 <c:formatCode>General</c:formatCode>
                 <c:ptCount val="3"/>
                 <c:pt idx="0">
-                  <c:v>65.946033049103249</c:v>
+                  <c:v>25.0</c:v>
                 </c:pt>
                 <c:pt idx="1">
-                  <c:v>68.979012870753891</c:v>
+                  <c:v>25.0</c:v>
                 </c:pt>
                 <c:pt idx="2">
-                  <c:v>67.88248623947581</c:v>
+                  <c:v>25.0</c:v>
                 </c:pt>
               </c:numCache>
             </c:numRef>
@@ -5073,13 +5073,13 @@
                 <c:formatCode>General</c:formatCode>
                 <c:ptCount val="3"/>
                 <c:pt idx="0">
-                  <c:v>19.831260027281679</c:v>
+                  <c:v>25.0</c:v>
                 </c:pt>
                 <c:pt idx="1">
-                  <c:v>18.027639550628933</c:v>
+                  <c:v>25.0</c:v>
                 </c:pt>
                 <c:pt idx="2">
-                  <c:v>18.635987231355021</c:v>
+                  <c:v>25.0</c:v>
                 </c:pt>
               </c:numCache>
             </c:numRef>
@@ -5149,13 +5149,13 @@
                 <c:formatCode>General</c:formatCode>
                 <c:ptCount val="3"/>
                 <c:pt idx="0">
-                  <c:v>6.1452471904275461</c:v>
+                  <c:v>25.0</c:v>
                 </c:pt>
                 <c:pt idx="1">
-                  <c:v>6.3315828505243328</c:v>
+                  <c:v>25.0</c:v>
                 </c:pt>
                 <c:pt idx="2">
-                  <c:v>6.7738131588832795</c:v>
+                  <c:v>25.0</c:v>
                 </c:pt>
               </c:numCache>
             </c:numRef>
@@ -5225,13 +5225,13 @@
                 <c:formatCode>General</c:formatCode>
                 <c:ptCount val="3"/>
                 <c:pt idx="0">
-                  <c:v>8.0774597331875206</c:v>
+                  <c:v>25.0</c:v>
                 </c:pt>
                 <c:pt idx="1">
-                  <c:v>6.6617647280928489</c:v>
+                  <c:v>25.0</c:v>
                 </c:pt>
                 <c:pt idx="2">
-                  <c:v>6.7077133702858811</c:v>
+                  <c:v>25.0</c:v>
                 </c:pt>
               </c:numCache>
             </c:numRef>
@@ -5452,13 +5452,13 @@
                 <c:formatCode>General</c:formatCode>
                 <c:ptCount val="3"/>
                 <c:pt idx="0">
-                  <c:v>91.563113353200137</c:v>
+                  <c:v>25.0</c:v>
                 </c:pt>
                 <c:pt idx="1">
-                  <c:v>93.70091119527585</c:v>
+                  <c:v>25.0</c:v>
                 </c:pt>
                 <c:pt idx="2">
-                  <c:v>93.138279672671914</c:v>
+                  <c:v>25.0</c:v>
                 </c:pt>
               </c:numCache>
             </c:numRef>
@@ -5528,13 +5528,13 @@
                 <c:formatCode>General</c:formatCode>
                 <c:ptCount val="3"/>
                 <c:pt idx="0">
-                  <c:v>5.5168803757830922</c:v>
+                  <c:v>25.0</c:v>
                 </c:pt>
                 <c:pt idx="1">
-                  <c:v>3.6913952296335024</c:v>
+                  <c:v>25.0</c:v>
                 </c:pt>
                 <c:pt idx="2">
-                  <c:v>3.8955853171314567</c:v>
+                  <c:v>25.0</c:v>
                 </c:pt>
               </c:numCache>
             </c:numRef>
@@ -5604,13 +5604,13 @@
                 <c:formatCode>General</c:formatCode>
                 <c:ptCount val="3"/>
                 <c:pt idx="0">
-                  <c:v>2.5725857976115076</c:v>
+                  <c:v>25.0</c:v>
                 </c:pt>
                 <c:pt idx="1">
-                  <c:v>2.4306038432397883</c:v>
+                  <c:v>25.0</c:v>
                 </c:pt>
                 <c:pt idx="2">
-                  <c:v>2.4576948730344634</c:v>
+                  <c:v>25.0</c:v>
                 </c:pt>
               </c:numCache>
             </c:numRef>
@@ -5680,13 +5680,13 @@
                 <c:formatCode>General</c:formatCode>
                 <c:ptCount val="3"/>
                 <c:pt idx="0">
-                  <c:v>0.34742047340526355</c:v>
+                  <c:v>25.0</c:v>
                 </c:pt>
                 <c:pt idx="1">
-                  <c:v>0.17708973185086063</c:v>
+                  <c:v>25.0</c:v>
                 </c:pt>
                 <c:pt idx="2">
-                  <c:v>0.50844013716217318</c:v>
+                  <c:v>25.0</c:v>
                 </c:pt>
               </c:numCache>
             </c:numRef>
@@ -5907,13 +5907,13 @@
                 <c:formatCode>General</c:formatCode>
                 <c:ptCount val="3"/>
                 <c:pt idx="0">
-                  <c:v>82.550393995004484</c:v>
+                  <c:v>25.0</c:v>
                 </c:pt>
                 <c:pt idx="1">
-                  <c:v>86.038125514687991</c:v>
+                  <c:v>25.0</c:v>
                 </c:pt>
                 <c:pt idx="2">
-                  <c:v>85.926814048418038</c:v>
+                  <c:v>25.0</c:v>
                 </c:pt>
               </c:numCache>
             </c:numRef>
@@ -5983,13 +5983,13 @@
                 <c:formatCode>General</c:formatCode>
                 <c:ptCount val="3"/>
                 <c:pt idx="0">
-                  <c:v>15.355997479537963</c:v>
+                  <c:v>25.0</c:v>
                 </c:pt>
                 <c:pt idx="1">
-                  <c:v>11.223480292398961</c:v>
+                  <c:v>25.0</c:v>
                 </c:pt>
                 <c:pt idx="2">
-                  <c:v>11.415547728807418</c:v>
+                  <c:v>25.0</c:v>
                 </c:pt>
               </c:numCache>
             </c:numRef>
@@ -6059,13 +6059,13 @@
                 <c:formatCode>General</c:formatCode>
                 <c:ptCount val="3"/>
                 <c:pt idx="0">
-                  <c:v>1.5225306614771383</c:v>
+                  <c:v>25.0</c:v>
                 </c:pt>
                 <c:pt idx="1">
-                  <c:v>1.751068731864855</c:v>
+                  <c:v>25.0</c:v>
                 </c:pt>
                 <c:pt idx="2">
-                  <c:v>1.6979773018683901</c:v>
+                  <c:v>25.0</c:v>
                 </c:pt>
               </c:numCache>
             </c:numRef>
@@ -6135,13 +6135,13 @@
                 <c:formatCode>General</c:formatCode>
                 <c:ptCount val="3"/>
                 <c:pt idx="0">
-                  <c:v>0.57107786398040727</c:v>
+                  <c:v>25.0</c:v>
                 </c:pt>
                 <c:pt idx="1">
-                  <c:v>0.98732546104818952</c:v>
+                  <c:v>25.0</c:v>
                 </c:pt>
                 <c:pt idx="2">
-                  <c:v>0.95966092090614874</c:v>
+                  <c:v>25.0</c:v>
                 </c:pt>
               </c:numCache>
             </c:numRef>

</xml_diff>